<commit_message>
fix(horizon): added pwa and diff pwa/webassembly
</commit_message>
<xml_diff>
--- a/supports/01-horizon-mobile.pptx
+++ b/supports/01-horizon-mobile.pptx
@@ -132,6 +132,30 @@
 <file path=ppt/changesInfos/changesInfo1.xml><?xml version="1.0" encoding="utf-8"?>
 <pc:chgInfo xmlns:a="http://schemas.openxmlformats.org/drawingml/2006/main" xmlns:r="http://schemas.openxmlformats.org/officeDocument/2006/relationships" xmlns:ac="http://schemas.microsoft.com/office/drawing/2013/main/command" xmlns:pc="http://schemas.microsoft.com/office/powerpoint/2013/main/command">
   <pc:docChgLst>
+    <pc:chgData name="Jonathan Melly" userId="a7718738-f2aa-4d1b-bcf4-5a9c900fe107" providerId="ADAL" clId="{205B7693-1168-4922-A193-3516E357791C}"/>
+    <pc:docChg chg="modSld">
+      <pc:chgData name="Jonathan Melly" userId="a7718738-f2aa-4d1b-bcf4-5a9c900fe107" providerId="ADAL" clId="{205B7693-1168-4922-A193-3516E357791C}" dt="2024-01-12T11:16:41.173" v="10" actId="20577"/>
+      <pc:docMkLst>
+        <pc:docMk/>
+      </pc:docMkLst>
+      <pc:sldChg chg="modSp">
+        <pc:chgData name="Jonathan Melly" userId="a7718738-f2aa-4d1b-bcf4-5a9c900fe107" providerId="ADAL" clId="{205B7693-1168-4922-A193-3516E357791C}" dt="2024-01-12T11:16:41.173" v="10" actId="20577"/>
+        <pc:sldMkLst>
+          <pc:docMk/>
+          <pc:sldMk cId="1436272467" sldId="257"/>
+        </pc:sldMkLst>
+        <pc:spChg chg="mod">
+          <ac:chgData name="Jonathan Melly" userId="a7718738-f2aa-4d1b-bcf4-5a9c900fe107" providerId="ADAL" clId="{205B7693-1168-4922-A193-3516E357791C}" dt="2024-01-12T11:16:41.173" v="10" actId="20577"/>
+          <ac:spMkLst>
+            <pc:docMk/>
+            <pc:sldMk cId="1436272467" sldId="257"/>
+            <ac:spMk id="3" creationId="{00000000-0000-0000-0000-000000000000}"/>
+          </ac:spMkLst>
+        </pc:spChg>
+      </pc:sldChg>
+    </pc:docChg>
+  </pc:docChgLst>
+  <pc:docChgLst>
     <pc:chgData name="Jonathan Melly" userId="a7718738-f2aa-4d1b-bcf4-5a9c900fe107" providerId="ADAL" clId="{708E095C-8A68-401A-B632-51D81A6E5807}"/>
     <pc:docChg chg="custSel modSld">
       <pc:chgData name="Jonathan Melly" userId="a7718738-f2aa-4d1b-bcf4-5a9c900fe107" providerId="ADAL" clId="{708E095C-8A68-401A-B632-51D81A6E5807}" dt="2024-02-04T07:06:40.589" v="8" actId="20577"/>
@@ -146,30 +170,6 @@
         </pc:sldMkLst>
         <pc:spChg chg="mod">
           <ac:chgData name="Jonathan Melly" userId="a7718738-f2aa-4d1b-bcf4-5a9c900fe107" providerId="ADAL" clId="{708E095C-8A68-401A-B632-51D81A6E5807}" dt="2024-02-04T07:06:40.589" v="8" actId="20577"/>
-          <ac:spMkLst>
-            <pc:docMk/>
-            <pc:sldMk cId="1436272467" sldId="257"/>
-            <ac:spMk id="3" creationId="{00000000-0000-0000-0000-000000000000}"/>
-          </ac:spMkLst>
-        </pc:spChg>
-      </pc:sldChg>
-    </pc:docChg>
-  </pc:docChgLst>
-  <pc:docChgLst>
-    <pc:chgData name="Jonathan Melly" userId="a7718738-f2aa-4d1b-bcf4-5a9c900fe107" providerId="ADAL" clId="{205B7693-1168-4922-A193-3516E357791C}"/>
-    <pc:docChg chg="modSld">
-      <pc:chgData name="Jonathan Melly" userId="a7718738-f2aa-4d1b-bcf4-5a9c900fe107" providerId="ADAL" clId="{205B7693-1168-4922-A193-3516E357791C}" dt="2024-01-12T11:16:41.173" v="10" actId="20577"/>
-      <pc:docMkLst>
-        <pc:docMk/>
-      </pc:docMkLst>
-      <pc:sldChg chg="modSp">
-        <pc:chgData name="Jonathan Melly" userId="a7718738-f2aa-4d1b-bcf4-5a9c900fe107" providerId="ADAL" clId="{205B7693-1168-4922-A193-3516E357791C}" dt="2024-01-12T11:16:41.173" v="10" actId="20577"/>
-        <pc:sldMkLst>
-          <pc:docMk/>
-          <pc:sldMk cId="1436272467" sldId="257"/>
-        </pc:sldMkLst>
-        <pc:spChg chg="mod">
-          <ac:chgData name="Jonathan Melly" userId="a7718738-f2aa-4d1b-bcf4-5a9c900fe107" providerId="ADAL" clId="{205B7693-1168-4922-A193-3516E357791C}" dt="2024-01-12T11:16:41.173" v="10" actId="20577"/>
           <ac:spMkLst>
             <pc:docMk/>
             <pc:sldMk cId="1436272467" sldId="257"/>
@@ -515,7 +515,7 @@
           <a:p>
             <a:fld id="{F625B7B3-C16C-0642-B771-3B9666D1AD77}" type="datetimeFigureOut">
               <a:rPr lang="fr-FR" smtClean="0"/>
-              <a:t>04/02/2024</a:t>
+              <a:t>16/03/2026</a:t>
             </a:fld>
             <a:endParaRPr lang="fr-FR"/>
           </a:p>
@@ -1103,7 +1103,7 @@
           <a:p>
             <a:fld id="{38ABC625-99CF-4929-861B-B0B3CEC37B7F}" type="datetimeFigureOut">
               <a:rPr lang="fr-CH" smtClean="0"/>
-              <a:t>04.02.2024</a:t>
+              <a:t>16.03.2026</a:t>
             </a:fld>
             <a:endParaRPr lang="fr-CH"/>
           </a:p>
@@ -1273,7 +1273,7 @@
           <a:p>
             <a:fld id="{38ABC625-99CF-4929-861B-B0B3CEC37B7F}" type="datetimeFigureOut">
               <a:rPr lang="fr-CH" smtClean="0"/>
-              <a:t>04.02.2024</a:t>
+              <a:t>16.03.2026</a:t>
             </a:fld>
             <a:endParaRPr lang="fr-CH"/>
           </a:p>
@@ -1453,7 +1453,7 @@
           <a:p>
             <a:fld id="{38ABC625-99CF-4929-861B-B0B3CEC37B7F}" type="datetimeFigureOut">
               <a:rPr lang="fr-CH" smtClean="0"/>
-              <a:t>04.02.2024</a:t>
+              <a:t>16.03.2026</a:t>
             </a:fld>
             <a:endParaRPr lang="fr-CH"/>
           </a:p>
@@ -1623,7 +1623,7 @@
           <a:p>
             <a:fld id="{38ABC625-99CF-4929-861B-B0B3CEC37B7F}" type="datetimeFigureOut">
               <a:rPr lang="fr-CH" smtClean="0"/>
-              <a:t>04.02.2024</a:t>
+              <a:t>16.03.2026</a:t>
             </a:fld>
             <a:endParaRPr lang="fr-CH"/>
           </a:p>
@@ -1869,7 +1869,7 @@
           <a:p>
             <a:fld id="{38ABC625-99CF-4929-861B-B0B3CEC37B7F}" type="datetimeFigureOut">
               <a:rPr lang="fr-CH" smtClean="0"/>
-              <a:t>04.02.2024</a:t>
+              <a:t>16.03.2026</a:t>
             </a:fld>
             <a:endParaRPr lang="fr-CH"/>
           </a:p>
@@ -2101,7 +2101,7 @@
           <a:p>
             <a:fld id="{38ABC625-99CF-4929-861B-B0B3CEC37B7F}" type="datetimeFigureOut">
               <a:rPr lang="fr-CH" smtClean="0"/>
-              <a:t>04.02.2024</a:t>
+              <a:t>16.03.2026</a:t>
             </a:fld>
             <a:endParaRPr lang="fr-CH"/>
           </a:p>
@@ -2468,7 +2468,7 @@
           <a:p>
             <a:fld id="{38ABC625-99CF-4929-861B-B0B3CEC37B7F}" type="datetimeFigureOut">
               <a:rPr lang="fr-CH" smtClean="0"/>
-              <a:t>04.02.2024</a:t>
+              <a:t>16.03.2026</a:t>
             </a:fld>
             <a:endParaRPr lang="fr-CH"/>
           </a:p>
@@ -2586,7 +2586,7 @@
           <a:p>
             <a:fld id="{38ABC625-99CF-4929-861B-B0B3CEC37B7F}" type="datetimeFigureOut">
               <a:rPr lang="fr-CH" smtClean="0"/>
-              <a:t>04.02.2024</a:t>
+              <a:t>16.03.2026</a:t>
             </a:fld>
             <a:endParaRPr lang="fr-CH"/>
           </a:p>
@@ -2681,7 +2681,7 @@
           <a:p>
             <a:fld id="{38ABC625-99CF-4929-861B-B0B3CEC37B7F}" type="datetimeFigureOut">
               <a:rPr lang="fr-CH" smtClean="0"/>
-              <a:t>04.02.2024</a:t>
+              <a:t>16.03.2026</a:t>
             </a:fld>
             <a:endParaRPr lang="fr-CH"/>
           </a:p>
@@ -2958,7 +2958,7 @@
           <a:p>
             <a:fld id="{38ABC625-99CF-4929-861B-B0B3CEC37B7F}" type="datetimeFigureOut">
               <a:rPr lang="fr-CH" smtClean="0"/>
-              <a:t>04.02.2024</a:t>
+              <a:t>16.03.2026</a:t>
             </a:fld>
             <a:endParaRPr lang="fr-CH"/>
           </a:p>
@@ -3211,7 +3211,7 @@
           <a:p>
             <a:fld id="{38ABC625-99CF-4929-861B-B0B3CEC37B7F}" type="datetimeFigureOut">
               <a:rPr lang="fr-CH" smtClean="0"/>
-              <a:t>04.02.2024</a:t>
+              <a:t>16.03.2026</a:t>
             </a:fld>
             <a:endParaRPr lang="fr-CH"/>
           </a:p>
@@ -3424,7 +3424,7 @@
           <a:p>
             <a:fld id="{38ABC625-99CF-4929-861B-B0B3CEC37B7F}" type="datetimeFigureOut">
               <a:rPr lang="fr-CH" smtClean="0"/>
-              <a:t>04.02.2024</a:t>
+              <a:t>16.03.2026</a:t>
             </a:fld>
             <a:endParaRPr lang="fr-CH"/>
           </a:p>
@@ -4138,73 +4138,73 @@
           <a:custGeom>
             <a:avLst/>
             <a:gdLst>
-              <a:gd name="connsiteX0" fmla="*/ 0 w 3474720"/>
-              <a:gd name="connsiteY0" fmla="*/ 0 h 18288"/>
-              <a:gd name="connsiteX1" fmla="*/ 694944 w 3474720"/>
-              <a:gd name="connsiteY1" fmla="*/ 0 h 18288"/>
-              <a:gd name="connsiteX2" fmla="*/ 1355141 w 3474720"/>
-              <a:gd name="connsiteY2" fmla="*/ 0 h 18288"/>
-              <a:gd name="connsiteX3" fmla="*/ 2015338 w 3474720"/>
-              <a:gd name="connsiteY3" fmla="*/ 0 h 18288"/>
-              <a:gd name="connsiteX4" fmla="*/ 2779776 w 3474720"/>
-              <a:gd name="connsiteY4" fmla="*/ 0 h 18288"/>
-              <a:gd name="connsiteX5" fmla="*/ 3474720 w 3474720"/>
-              <a:gd name="connsiteY5" fmla="*/ 0 h 18288"/>
-              <a:gd name="connsiteX6" fmla="*/ 3474720 w 3474720"/>
-              <a:gd name="connsiteY6" fmla="*/ 18288 h 18288"/>
-              <a:gd name="connsiteX7" fmla="*/ 2779776 w 3474720"/>
-              <a:gd name="connsiteY7" fmla="*/ 18288 h 18288"/>
-              <a:gd name="connsiteX8" fmla="*/ 2189074 w 3474720"/>
-              <a:gd name="connsiteY8" fmla="*/ 18288 h 18288"/>
-              <a:gd name="connsiteX9" fmla="*/ 1528877 w 3474720"/>
-              <a:gd name="connsiteY9" fmla="*/ 18288 h 18288"/>
-              <a:gd name="connsiteX10" fmla="*/ 868680 w 3474720"/>
-              <a:gd name="connsiteY10" fmla="*/ 18288 h 18288"/>
-              <a:gd name="connsiteX11" fmla="*/ 0 w 3474720"/>
-              <a:gd name="connsiteY11" fmla="*/ 18288 h 18288"/>
-              <a:gd name="connsiteX12" fmla="*/ 0 w 3474720"/>
-              <a:gd name="connsiteY12" fmla="*/ 0 h 18288"/>
+              <a:gd name="csX0" fmla="*/ 0 w 3474720"/>
+              <a:gd name="csY0" fmla="*/ 0 h 18288"/>
+              <a:gd name="csX1" fmla="*/ 694944 w 3474720"/>
+              <a:gd name="csY1" fmla="*/ 0 h 18288"/>
+              <a:gd name="csX2" fmla="*/ 1355141 w 3474720"/>
+              <a:gd name="csY2" fmla="*/ 0 h 18288"/>
+              <a:gd name="csX3" fmla="*/ 2015338 w 3474720"/>
+              <a:gd name="csY3" fmla="*/ 0 h 18288"/>
+              <a:gd name="csX4" fmla="*/ 2779776 w 3474720"/>
+              <a:gd name="csY4" fmla="*/ 0 h 18288"/>
+              <a:gd name="csX5" fmla="*/ 3474720 w 3474720"/>
+              <a:gd name="csY5" fmla="*/ 0 h 18288"/>
+              <a:gd name="csX6" fmla="*/ 3474720 w 3474720"/>
+              <a:gd name="csY6" fmla="*/ 18288 h 18288"/>
+              <a:gd name="csX7" fmla="*/ 2779776 w 3474720"/>
+              <a:gd name="csY7" fmla="*/ 18288 h 18288"/>
+              <a:gd name="csX8" fmla="*/ 2189074 w 3474720"/>
+              <a:gd name="csY8" fmla="*/ 18288 h 18288"/>
+              <a:gd name="csX9" fmla="*/ 1528877 w 3474720"/>
+              <a:gd name="csY9" fmla="*/ 18288 h 18288"/>
+              <a:gd name="csX10" fmla="*/ 868680 w 3474720"/>
+              <a:gd name="csY10" fmla="*/ 18288 h 18288"/>
+              <a:gd name="csX11" fmla="*/ 0 w 3474720"/>
+              <a:gd name="csY11" fmla="*/ 18288 h 18288"/>
+              <a:gd name="csX12" fmla="*/ 0 w 3474720"/>
+              <a:gd name="csY12" fmla="*/ 0 h 18288"/>
             </a:gdLst>
             <a:ahLst/>
             <a:cxnLst>
               <a:cxn ang="0">
-                <a:pos x="connsiteX0" y="connsiteY0"/>
+                <a:pos x="csX0" y="csY0"/>
               </a:cxn>
               <a:cxn ang="0">
-                <a:pos x="connsiteX1" y="connsiteY1"/>
+                <a:pos x="csX1" y="csY1"/>
               </a:cxn>
               <a:cxn ang="0">
-                <a:pos x="connsiteX2" y="connsiteY2"/>
+                <a:pos x="csX2" y="csY2"/>
               </a:cxn>
               <a:cxn ang="0">
-                <a:pos x="connsiteX3" y="connsiteY3"/>
+                <a:pos x="csX3" y="csY3"/>
               </a:cxn>
               <a:cxn ang="0">
-                <a:pos x="connsiteX4" y="connsiteY4"/>
+                <a:pos x="csX4" y="csY4"/>
               </a:cxn>
               <a:cxn ang="0">
-                <a:pos x="connsiteX5" y="connsiteY5"/>
+                <a:pos x="csX5" y="csY5"/>
               </a:cxn>
               <a:cxn ang="0">
-                <a:pos x="connsiteX6" y="connsiteY6"/>
+                <a:pos x="csX6" y="csY6"/>
               </a:cxn>
               <a:cxn ang="0">
-                <a:pos x="connsiteX7" y="connsiteY7"/>
+                <a:pos x="csX7" y="csY7"/>
               </a:cxn>
               <a:cxn ang="0">
-                <a:pos x="connsiteX8" y="connsiteY8"/>
+                <a:pos x="csX8" y="csY8"/>
               </a:cxn>
               <a:cxn ang="0">
-                <a:pos x="connsiteX9" y="connsiteY9"/>
+                <a:pos x="csX9" y="csY9"/>
               </a:cxn>
               <a:cxn ang="0">
-                <a:pos x="connsiteX10" y="connsiteY10"/>
+                <a:pos x="csX10" y="csY10"/>
               </a:cxn>
               <a:cxn ang="0">
-                <a:pos x="connsiteX11" y="connsiteY11"/>
+                <a:pos x="csX11" y="csY11"/>
               </a:cxn>
               <a:cxn ang="0">
-                <a:pos x="connsiteX12" y="connsiteY12"/>
+                <a:pos x="csX12" y="csY12"/>
               </a:cxn>
             </a:cxnLst>
             <a:rect l="l" t="t" r="r" b="b"/>
@@ -4415,6 +4415,14 @@
             <a:r>
               <a:rPr lang="fr-FR" sz="1800" dirty="0"/>
               <a:t>Web (y.c. </a:t>
+            </a:r>
+            <a:r>
+              <a:rPr lang="fr-FR" sz="1800" dirty="0" err="1"/>
+              <a:t>pwa</a:t>
+            </a:r>
+            <a:r>
+              <a:rPr lang="fr-FR" sz="1800" dirty="0"/>
+              <a:t>  et </a:t>
             </a:r>
             <a:r>
               <a:rPr lang="fr-FR" sz="1800" dirty="0" err="1"/>
@@ -6870,17 +6878,6 @@
 </file>
 
 <file path=customXml/item2.xml><?xml version="1.0" encoding="utf-8"?>
-<p:properties xmlns:p="http://schemas.microsoft.com/office/2006/metadata/properties" xmlns:xsi="http://www.w3.org/2001/XMLSchema-instance" xmlns:pc="http://schemas.microsoft.com/office/infopath/2007/PartnerControls">
-  <documentManagement>
-    <lcf76f155ced4ddcb4097134ff3c332f xmlns="eb2b4dc0-5538-4988-a426-1e3bf3687743">
-      <Terms xmlns="http://schemas.microsoft.com/office/infopath/2007/PartnerControls"/>
-    </lcf76f155ced4ddcb4097134ff3c332f>
-    <TaxCatchAll xmlns="26488081-7094-48e3-a435-bbb366c5709a" xsi:nil="true"/>
-  </documentManagement>
-</p:properties>
-</file>
-
-<file path=customXml/item3.xml><?xml version="1.0" encoding="utf-8"?>
 <ct:contentTypeSchema xmlns:ct="http://schemas.microsoft.com/office/2006/metadata/contentType" xmlns:ma="http://schemas.microsoft.com/office/2006/metadata/properties/metaAttributes" ct:_="" ma:_="" ma:contentTypeName="Document" ma:contentTypeID="0x010100BD12CA962D3BC343BA4881942FCA9ABD" ma:contentTypeVersion="13" ma:contentTypeDescription="Crée un document." ma:contentTypeScope="" ma:versionID="45e4eb9c467ac1095cc278a4b870d57b">
   <xsd:schema xmlns:xsd="http://www.w3.org/2001/XMLSchema" xmlns:xs="http://www.w3.org/2001/XMLSchema" xmlns:p="http://schemas.microsoft.com/office/2006/metadata/properties" xmlns:ns2="eb2b4dc0-5538-4988-a426-1e3bf3687743" xmlns:ns3="26488081-7094-48e3-a435-bbb366c5709a" targetNamespace="http://schemas.microsoft.com/office/2006/metadata/properties" ma:root="true" ma:fieldsID="f5af6340369c61bec97e443d69464973" ns2:_="" ns3:_="">
     <xsd:import namespace="eb2b4dc0-5538-4988-a426-1e3bf3687743"/>
@@ -7087,6 +7084,17 @@
 </ct:contentTypeSchema>
 </file>
 
+<file path=customXml/item3.xml><?xml version="1.0" encoding="utf-8"?>
+<p:properties xmlns:p="http://schemas.microsoft.com/office/2006/metadata/properties" xmlns:xsi="http://www.w3.org/2001/XMLSchema-instance" xmlns:pc="http://schemas.microsoft.com/office/infopath/2007/PartnerControls">
+  <documentManagement>
+    <lcf76f155ced4ddcb4097134ff3c332f xmlns="eb2b4dc0-5538-4988-a426-1e3bf3687743">
+      <Terms xmlns="http://schemas.microsoft.com/office/infopath/2007/PartnerControls"/>
+    </lcf76f155ced4ddcb4097134ff3c332f>
+    <TaxCatchAll xmlns="26488081-7094-48e3-a435-bbb366c5709a" xsi:nil="true"/>
+  </documentManagement>
+</p:properties>
+</file>
+
 <file path=customXml/itemProps1.xml><?xml version="1.0" encoding="utf-8"?>
 <ds:datastoreItem xmlns:ds="http://schemas.openxmlformats.org/officeDocument/2006/customXml" ds:itemID="{F5B8D1DF-AD42-47B1-98CB-3EF0AF73B79B}">
   <ds:schemaRefs>
@@ -7096,6 +7104,25 @@
 </file>
 
 <file path=customXml/itemProps2.xml><?xml version="1.0" encoding="utf-8"?>
+<ds:datastoreItem xmlns:ds="http://schemas.openxmlformats.org/officeDocument/2006/customXml" ds:itemID="{A6E34C0B-2FD5-4A6F-BD95-9378FC419003}">
+  <ds:schemaRefs>
+    <ds:schemaRef ds:uri="http://schemas.microsoft.com/office/2006/metadata/contentType"/>
+    <ds:schemaRef ds:uri="http://schemas.microsoft.com/office/2006/metadata/properties/metaAttributes"/>
+    <ds:schemaRef ds:uri="http://www.w3.org/2001/XMLSchema"/>
+    <ds:schemaRef ds:uri="http://schemas.microsoft.com/office/2006/metadata/properties"/>
+    <ds:schemaRef ds:uri="eb2b4dc0-5538-4988-a426-1e3bf3687743"/>
+    <ds:schemaRef ds:uri="26488081-7094-48e3-a435-bbb366c5709a"/>
+    <ds:schemaRef ds:uri="http://schemas.microsoft.com/office/2006/documentManagement/types"/>
+    <ds:schemaRef ds:uri="http://schemas.microsoft.com/office/infopath/2007/PartnerControls"/>
+    <ds:schemaRef ds:uri="http://schemas.openxmlformats.org/package/2006/metadata/core-properties"/>
+    <ds:schemaRef ds:uri="http://purl.org/dc/elements/1.1/"/>
+    <ds:schemaRef ds:uri="http://purl.org/dc/terms/"/>
+    <ds:schemaRef ds:uri="http://schemas.microsoft.com/internal/obd"/>
+  </ds:schemaRefs>
+</ds:datastoreItem>
+</file>
+
+<file path=customXml/itemProps3.xml><?xml version="1.0" encoding="utf-8"?>
 <ds:datastoreItem xmlns:ds="http://schemas.openxmlformats.org/officeDocument/2006/customXml" ds:itemID="{B5410D64-ADF5-4610-9E98-1638A170244F}">
   <ds:schemaRefs>
     <ds:schemaRef ds:uri="f7d9f5a6-831d-4621-8c77-cbcaf993e406"/>
@@ -7109,10 +7136,8 @@
     <ds:schemaRef ds:uri="http://schemas.microsoft.com/office/infopath/2007/PartnerControls"/>
     <ds:schemaRef ds:uri="http://schemas.openxmlformats.org/package/2006/metadata/core-properties"/>
     <ds:schemaRef ds:uri="http://purl.org/dc/dcmitype/"/>
+    <ds:schemaRef ds:uri="eb2b4dc0-5538-4988-a426-1e3bf3687743"/>
+    <ds:schemaRef ds:uri="26488081-7094-48e3-a435-bbb366c5709a"/>
   </ds:schemaRefs>
 </ds:datastoreItem>
-</file>
-
-<file path=customXml/itemProps3.xml><?xml version="1.0" encoding="utf-8"?>
-<ds:datastoreItem xmlns:ds="http://schemas.openxmlformats.org/officeDocument/2006/customXml" ds:itemID="{A6E34C0B-2FD5-4A6F-BD95-9378FC419003}"/>
 </file>
</xml_diff>